<commit_message>
Add one-command run_all, regression checks, and fix PPT hardcoding
- scripts/run_all.py: run the whole pipeline with a single --source raw|sample
  (only preprocess takes the flag; everything downstream reads data/processed,
  so a run cannot mix sources). --skip-ppt to skip the PowerPoint builders.
- scripts/check_pipeline.py: run the sample pipeline and assert key invariants
  (sample counts, September split, model sanity, decorrelated importance,
  NaN-safe benefit rate, source/survivorship/small-n labels).
- build_final_report_ppt.py / build_teacher_ppt.py: drop the hardcoded "116명"
  (a stale real-data leftover), compute analysis n from the live table, and add
  a data-source caption slide from the manifest.
- dataset_meta.source_caption(): plain-text source line for slides.
- README: document run_all, --source, and check_pipeline.

Co-Authored-By: Claude Opus 4.8 <noreply@anthropic.com>
</commit_message>
<xml_diff>
--- a/output/reports/final_insight_report_internal_share.pptx
+++ b/output/reports/final_insight_report_internal_share.pptx
@@ -175,9 +175,9 @@
           </c:spPr>
           <c:cat>
             <c:strRef>
-              <c:f>Sheet1!$A$2:$A$10</c:f>
+              <c:f>Sheet1!$A$2:$A$11</c:f>
               <c:strCache>
-                <c:ptCount val="9"/>
+                <c:ptCount val="10"/>
                 <c:pt idx="0">
                   <c:v>3월</c:v>
                 </c:pt>
@@ -197,12 +197,15 @@
                   <c:v>8월</c:v>
                 </c:pt>
                 <c:pt idx="6">
-                  <c:v>9월</c:v>
+                  <c:v>9월(사)</c:v>
                 </c:pt>
                 <c:pt idx="7">
+                  <c:v>9월(평)</c:v>
+                </c:pt>
+                <c:pt idx="8">
                   <c:v>10월</c:v>
                 </c:pt>
-                <c:pt idx="8">
+                <c:pt idx="9">
                   <c:v>11월</c:v>
                 </c:pt>
               </c:strCache>
@@ -210,10 +213,10 @@
           </c:cat>
           <c:val>
             <c:numRef>
-              <c:f>Sheet1!$B$2:$B$10</c:f>
+              <c:f>Sheet1!$B$2:$B$11</c:f>
               <c:numCache>
                 <c:formatCode>General</c:formatCode>
-                <c:ptCount val="9"/>
+                <c:ptCount val="10"/>
                 <c:pt idx="0">
                   <c:v>89.0</c:v>
                 </c:pt>
@@ -233,12 +236,15 @@
                   <c:v>90.4</c:v>
                 </c:pt>
                 <c:pt idx="6">
-                  <c:v>92.4</c:v>
+                  <c:v>92.7</c:v>
                 </c:pt>
                 <c:pt idx="7">
+                  <c:v>92.2</c:v>
+                </c:pt>
+                <c:pt idx="8">
                   <c:v>91.5</c:v>
                 </c:pt>
-                <c:pt idx="8">
+                <c:pt idx="9">
                   <c:v>91.9</c:v>
                 </c:pt>
               </c:numCache>
@@ -269,9 +275,9 @@
           </c:spPr>
           <c:cat>
             <c:strRef>
-              <c:f>Sheet1!$A$2:$A$10</c:f>
+              <c:f>Sheet1!$A$2:$A$11</c:f>
               <c:strCache>
-                <c:ptCount val="9"/>
+                <c:ptCount val="10"/>
                 <c:pt idx="0">
                   <c:v>3월</c:v>
                 </c:pt>
@@ -291,12 +297,15 @@
                   <c:v>8월</c:v>
                 </c:pt>
                 <c:pt idx="6">
-                  <c:v>9월</c:v>
+                  <c:v>9월(사)</c:v>
                 </c:pt>
                 <c:pt idx="7">
+                  <c:v>9월(평)</c:v>
+                </c:pt>
+                <c:pt idx="8">
                   <c:v>10월</c:v>
                 </c:pt>
-                <c:pt idx="8">
+                <c:pt idx="9">
                   <c:v>11월</c:v>
                 </c:pt>
               </c:strCache>
@@ -304,10 +313,10 @@
           </c:cat>
           <c:val>
             <c:numRef>
-              <c:f>Sheet1!$C$2:$C$10</c:f>
+              <c:f>Sheet1!$C$2:$C$11</c:f>
               <c:numCache>
                 <c:formatCode>General</c:formatCode>
-                <c:ptCount val="9"/>
+                <c:ptCount val="10"/>
                 <c:pt idx="0">
                   <c:v>76.5</c:v>
                 </c:pt>
@@ -327,12 +336,15 @@
                   <c:v>78.7</c:v>
                 </c:pt>
                 <c:pt idx="6">
-                  <c:v>79.5</c:v>
+                  <c:v>79.4</c:v>
                 </c:pt>
                 <c:pt idx="7">
+                  <c:v>79.7</c:v>
+                </c:pt>
+                <c:pt idx="8">
                   <c:v>81.1</c:v>
                 </c:pt>
-                <c:pt idx="8">
+                <c:pt idx="9">
                   <c:v>81.0</c:v>
                 </c:pt>
               </c:numCache>
@@ -363,9 +375,9 @@
           </c:spPr>
           <c:cat>
             <c:strRef>
-              <c:f>Sheet1!$A$2:$A$10</c:f>
+              <c:f>Sheet1!$A$2:$A$11</c:f>
               <c:strCache>
-                <c:ptCount val="9"/>
+                <c:ptCount val="10"/>
                 <c:pt idx="0">
                   <c:v>3월</c:v>
                 </c:pt>
@@ -385,12 +397,15 @@
                   <c:v>8월</c:v>
                 </c:pt>
                 <c:pt idx="6">
-                  <c:v>9월</c:v>
+                  <c:v>9월(사)</c:v>
                 </c:pt>
                 <c:pt idx="7">
+                  <c:v>9월(평)</c:v>
+                </c:pt>
+                <c:pt idx="8">
                   <c:v>10월</c:v>
                 </c:pt>
-                <c:pt idx="8">
+                <c:pt idx="9">
                   <c:v>11월</c:v>
                 </c:pt>
               </c:strCache>
@@ -398,10 +413,10 @@
           </c:cat>
           <c:val>
             <c:numRef>
-              <c:f>Sheet1!$D$2:$D$10</c:f>
+              <c:f>Sheet1!$D$2:$D$11</c:f>
               <c:numCache>
                 <c:formatCode>General</c:formatCode>
-                <c:ptCount val="9"/>
+                <c:ptCount val="10"/>
                 <c:pt idx="0">
                   <c:v>62.3</c:v>
                 </c:pt>
@@ -424,9 +439,12 @@
                   <c:v>63.6</c:v>
                 </c:pt>
                 <c:pt idx="7">
+                  <c:v>63.5</c:v>
+                </c:pt>
+                <c:pt idx="8">
                   <c:v>63.4</c:v>
                 </c:pt>
-                <c:pt idx="8">
+                <c:pt idx="9">
                   <c:v>63.5</c:v>
                 </c:pt>
               </c:numCache>
@@ -8919,7 +8937,7 @@
                 <a:gridCol w="914400"/>
                 <a:gridCol w="914400"/>
               </a:tblGrid>
-              <a:tr h="533400">
+              <a:tr h="457200">
                 <a:tc>
                   <a:txBody>
                     <a:bodyPr/>
@@ -9065,7 +9083,7 @@
                   </a:tcPr>
                 </a:tc>
               </a:tr>
-              <a:tr h="533400">
+              <a:tr h="457200">
                 <a:tc>
                   <a:txBody>
                     <a:bodyPr/>
@@ -9187,7 +9205,7 @@
                   <a:tcPr/>
                 </a:tc>
               </a:tr>
-              <a:tr h="533400">
+              <a:tr h="457200">
                 <a:tc>
                   <a:txBody>
                     <a:bodyPr/>
@@ -9309,129 +9327,251 @@
                   <a:tcPr/>
                 </a:tc>
               </a:tr>
-              <a:tr h="533400">
-                <a:tc>
-                  <a:txBody>
-                    <a:bodyPr/>
-                    <a:lstStyle/>
-                    <a:p>
-                      <a:pPr algn="ctr">
-                        <a:defRPr sz="700">
-                          <a:solidFill>
-                            <a:srgbClr val="374151"/>
-                          </a:solidFill>
-                          <a:latin typeface="Malgun Gothic"/>
-                        </a:defRPr>
-                      </a:pPr>
-                      <a:r>
-                        <a:t>9월</a:t>
-                      </a:r>
-                    </a:p>
-                  </a:txBody>
-                  <a:tcPr/>
-                </a:tc>
-                <a:tc>
-                  <a:txBody>
-                    <a:bodyPr/>
-                    <a:lstStyle/>
-                    <a:p>
-                      <a:pPr algn="ctr">
-                        <a:defRPr sz="700">
-                          <a:solidFill>
-                            <a:srgbClr val="374151"/>
-                          </a:solidFill>
-                          <a:latin typeface="Malgun Gothic"/>
-                        </a:defRPr>
-                      </a:pPr>
-                      <a:r>
-                        <a:t>9</a:t>
-                      </a:r>
-                    </a:p>
-                  </a:txBody>
-                  <a:tcPr/>
-                </a:tc>
-                <a:tc>
-                  <a:txBody>
-                    <a:bodyPr/>
-                    <a:lstStyle/>
-                    <a:p>
-                      <a:pPr algn="ctr">
-                        <a:defRPr sz="700">
-                          <a:solidFill>
-                            <a:srgbClr val="374151"/>
-                          </a:solidFill>
-                          <a:latin typeface="Malgun Gothic"/>
-                        </a:defRPr>
-                      </a:pPr>
-                      <a:r>
-                        <a:t>3.6</a:t>
-                      </a:r>
-                    </a:p>
-                  </a:txBody>
-                  <a:tcPr/>
-                </a:tc>
-                <a:tc>
-                  <a:txBody>
-                    <a:bodyPr/>
-                    <a:lstStyle/>
-                    <a:p>
-                      <a:pPr algn="ctr">
-                        <a:defRPr sz="700">
-                          <a:solidFill>
-                            <a:srgbClr val="374151"/>
-                          </a:solidFill>
-                          <a:latin typeface="Malgun Gothic"/>
-                        </a:defRPr>
-                      </a:pPr>
-                      <a:r>
-                        <a:t>6.2</a:t>
-                      </a:r>
-                    </a:p>
-                  </a:txBody>
-                  <a:tcPr/>
-                </a:tc>
-                <a:tc>
-                  <a:txBody>
-                    <a:bodyPr/>
-                    <a:lstStyle/>
-                    <a:p>
-                      <a:pPr algn="ctr">
-                        <a:defRPr sz="700">
-                          <a:solidFill>
-                            <a:srgbClr val="374151"/>
-                          </a:solidFill>
-                          <a:latin typeface="Malgun Gothic"/>
-                        </a:defRPr>
-                      </a:pPr>
-                      <a:r>
-                        <a:t>2.6</a:t>
-                      </a:r>
-                    </a:p>
-                  </a:txBody>
-                  <a:tcPr/>
-                </a:tc>
-                <a:tc>
-                  <a:txBody>
-                    <a:bodyPr/>
-                    <a:lstStyle/>
-                    <a:p>
-                      <a:pPr algn="ctr">
-                        <a:defRPr sz="700">
-                          <a:solidFill>
-                            <a:srgbClr val="374151"/>
-                          </a:solidFill>
-                          <a:latin typeface="Malgun Gothic"/>
-                        </a:defRPr>
-                      </a:pPr>
-                      <a:r>
-                        <a:t>66.7%</a:t>
+              <a:tr h="457200">
+                <a:tc>
+                  <a:txBody>
+                    <a:bodyPr/>
+                    <a:lstStyle/>
+                    <a:p>
+                      <a:pPr algn="ctr">
+                        <a:defRPr sz="700">
+                          <a:solidFill>
+                            <a:srgbClr val="374151"/>
+                          </a:solidFill>
+                          <a:latin typeface="Malgun Gothic"/>
+                        </a:defRPr>
+                      </a:pPr>
+                      <a:r>
+                        <a:t>9월(사)</a:t>
+                      </a:r>
+                    </a:p>
+                  </a:txBody>
+                  <a:tcPr/>
+                </a:tc>
+                <a:tc>
+                  <a:txBody>
+                    <a:bodyPr/>
+                    <a:lstStyle/>
+                    <a:p>
+                      <a:pPr algn="ctr">
+                        <a:defRPr sz="700">
+                          <a:solidFill>
+                            <a:srgbClr val="374151"/>
+                          </a:solidFill>
+                          <a:latin typeface="Malgun Gothic"/>
+                        </a:defRPr>
+                      </a:pPr>
+                      <a:r>
+                        <a:t>5</a:t>
+                      </a:r>
+                    </a:p>
+                  </a:txBody>
+                  <a:tcPr/>
+                </a:tc>
+                <a:tc>
+                  <a:txBody>
+                    <a:bodyPr/>
+                    <a:lstStyle/>
+                    <a:p>
+                      <a:pPr algn="ctr">
+                        <a:defRPr sz="700">
+                          <a:solidFill>
+                            <a:srgbClr val="374151"/>
+                          </a:solidFill>
+                          <a:latin typeface="Malgun Gothic"/>
+                        </a:defRPr>
+                      </a:pPr>
+                      <a:r>
+                        <a:t>1.1</a:t>
+                      </a:r>
+                    </a:p>
+                  </a:txBody>
+                  <a:tcPr/>
+                </a:tc>
+                <a:tc>
+                  <a:txBody>
+                    <a:bodyPr/>
+                    <a:lstStyle/>
+                    <a:p>
+                      <a:pPr algn="ctr">
+                        <a:defRPr sz="700">
+                          <a:solidFill>
+                            <a:srgbClr val="374151"/>
+                          </a:solidFill>
+                          <a:latin typeface="Malgun Gothic"/>
+                        </a:defRPr>
+                      </a:pPr>
+                      <a:r>
+                        <a:t>2.0</a:t>
+                      </a:r>
+                    </a:p>
+                  </a:txBody>
+                  <a:tcPr/>
+                </a:tc>
+                <a:tc>
+                  <a:txBody>
+                    <a:bodyPr/>
+                    <a:lstStyle/>
+                    <a:p>
+                      <a:pPr algn="ctr">
+                        <a:defRPr sz="700">
+                          <a:solidFill>
+                            <a:srgbClr val="374151"/>
+                          </a:solidFill>
+                          <a:latin typeface="Malgun Gothic"/>
+                        </a:defRPr>
+                      </a:pPr>
+                      <a:r>
+                        <a:t>0.9</a:t>
+                      </a:r>
+                    </a:p>
+                  </a:txBody>
+                  <a:tcPr/>
+                </a:tc>
+                <a:tc>
+                  <a:txBody>
+                    <a:bodyPr/>
+                    <a:lstStyle/>
+                    <a:p>
+                      <a:pPr algn="ctr">
+                        <a:defRPr sz="700">
+                          <a:solidFill>
+                            <a:srgbClr val="374151"/>
+                          </a:solidFill>
+                          <a:latin typeface="Malgun Gothic"/>
+                        </a:defRPr>
+                      </a:pPr>
+                      <a:r>
+                        <a:t>60.0%</a:t>
                       </a:r>
                     </a:p>
                   </a:txBody>
                   <a:tcPr/>
                 </a:tc>
               </a:tr>
-              <a:tr h="533400">
+              <a:tr h="457200">
+                <a:tc>
+                  <a:txBody>
+                    <a:bodyPr/>
+                    <a:lstStyle/>
+                    <a:p>
+                      <a:pPr algn="ctr">
+                        <a:defRPr sz="700">
+                          <a:solidFill>
+                            <a:srgbClr val="374151"/>
+                          </a:solidFill>
+                          <a:latin typeface="Malgun Gothic"/>
+                        </a:defRPr>
+                      </a:pPr>
+                      <a:r>
+                        <a:t>9월(평)</a:t>
+                      </a:r>
+                    </a:p>
+                  </a:txBody>
+                  <a:tcPr/>
+                </a:tc>
+                <a:tc>
+                  <a:txBody>
+                    <a:bodyPr/>
+                    <a:lstStyle/>
+                    <a:p>
+                      <a:pPr algn="ctr">
+                        <a:defRPr sz="700">
+                          <a:solidFill>
+                            <a:srgbClr val="374151"/>
+                          </a:solidFill>
+                          <a:latin typeface="Malgun Gothic"/>
+                        </a:defRPr>
+                      </a:pPr>
+                      <a:r>
+                        <a:t>4</a:t>
+                      </a:r>
+                    </a:p>
+                  </a:txBody>
+                  <a:tcPr/>
+                </a:tc>
+                <a:tc>
+                  <a:txBody>
+                    <a:bodyPr/>
+                    <a:lstStyle/>
+                    <a:p>
+                      <a:pPr algn="ctr">
+                        <a:defRPr sz="700">
+                          <a:solidFill>
+                            <a:srgbClr val="374151"/>
+                          </a:solidFill>
+                          <a:latin typeface="Malgun Gothic"/>
+                        </a:defRPr>
+                      </a:pPr>
+                      <a:r>
+                        <a:t>6.6</a:t>
+                      </a:r>
+                    </a:p>
+                  </a:txBody>
+                  <a:tcPr/>
+                </a:tc>
+                <a:tc>
+                  <a:txBody>
+                    <a:bodyPr/>
+                    <a:lstStyle/>
+                    <a:p>
+                      <a:pPr algn="ctr">
+                        <a:defRPr sz="700">
+                          <a:solidFill>
+                            <a:srgbClr val="374151"/>
+                          </a:solidFill>
+                          <a:latin typeface="Malgun Gothic"/>
+                        </a:defRPr>
+                      </a:pPr>
+                      <a:r>
+                        <a:t>11.4</a:t>
+                      </a:r>
+                    </a:p>
+                  </a:txBody>
+                  <a:tcPr/>
+                </a:tc>
+                <a:tc>
+                  <a:txBody>
+                    <a:bodyPr/>
+                    <a:lstStyle/>
+                    <a:p>
+                      <a:pPr algn="ctr">
+                        <a:defRPr sz="700">
+                          <a:solidFill>
+                            <a:srgbClr val="374151"/>
+                          </a:solidFill>
+                          <a:latin typeface="Malgun Gothic"/>
+                        </a:defRPr>
+                      </a:pPr>
+                      <a:r>
+                        <a:t>4.8</a:t>
+                      </a:r>
+                    </a:p>
+                  </a:txBody>
+                  <a:tcPr/>
+                </a:tc>
+                <a:tc>
+                  <a:txBody>
+                    <a:bodyPr/>
+                    <a:lstStyle/>
+                    <a:p>
+                      <a:pPr algn="ctr">
+                        <a:defRPr sz="700">
+                          <a:solidFill>
+                            <a:srgbClr val="374151"/>
+                          </a:solidFill>
+                          <a:latin typeface="Malgun Gothic"/>
+                        </a:defRPr>
+                      </a:pPr>
+                      <a:r>
+                        <a:t>75.0%</a:t>
+                      </a:r>
+                    </a:p>
+                  </a:txBody>
+                  <a:tcPr/>
+                </a:tc>
+              </a:tr>
+              <a:tr h="457200">
                 <a:tc>
                   <a:txBody>
                     <a:bodyPr/>
@@ -9553,7 +9693,7 @@
                   <a:tcPr/>
                 </a:tc>
               </a:tr>
-              <a:tr h="533400">
+              <a:tr h="457200">
                 <a:tc>
                   <a:txBody>
                     <a:bodyPr/>
@@ -12634,7 +12774,7 @@
               <a:spcAft>
                 <a:spcPts val="800"/>
               </a:spcAft>
-              <a:defRPr sz="1700">
+              <a:defRPr sz="1600">
                 <a:solidFill>
                   <a:srgbClr val="374151"/>
                 </a:solidFill>
@@ -12642,7 +12782,7 @@
               </a:defRPr>
             </a:pPr>
             <a:r>
-              <a:t>분석 대상: 수능 이전 모의고사 기록과 수능 결과가 모두 있는 116명</a:t>
+              <a:t>데이터 출처: 공개용 더미(데모) · 전체 180명 · 수능결과 137명 · 분석 커버리지 137/180명 · 생성 2026-07-07T00:08:42</a:t>
             </a:r>
           </a:p>
           <a:p>
@@ -12650,7 +12790,23 @@
               <a:spcAft>
                 <a:spcPts val="800"/>
               </a:spcAft>
-              <a:defRPr sz="1700">
+              <a:defRPr sz="1600">
+                <a:solidFill>
+                  <a:srgbClr val="374151"/>
+                </a:solidFill>
+                <a:latin typeface="Malgun Gothic"/>
+              </a:defRPr>
+            </a:pPr>
+            <a:r>
+              <a:t>분석 대상: 수능 이전 모의고사 기록과 수능 결과가 모두 있는 137명</a:t>
+            </a:r>
+          </a:p>
+          <a:p>
+            <a:pPr>
+              <a:spcAft>
+                <a:spcPts val="800"/>
+              </a:spcAft>
+              <a:defRPr sz="1600">
                 <a:solidFill>
                   <a:srgbClr val="374151"/>
                 </a:solidFill>
@@ -12666,7 +12822,7 @@
               <a:spcAft>
                 <a:spcPts val="800"/>
               </a:spcAft>
-              <a:defRPr sz="1700">
+              <a:defRPr sz="1600">
                 <a:solidFill>
                   <a:srgbClr val="374151"/>
                 </a:solidFill>
@@ -12682,7 +12838,7 @@
               <a:spcAft>
                 <a:spcPts val="800"/>
               </a:spcAft>
-              <a:defRPr sz="1700">
+              <a:defRPr sz="1600">
                 <a:solidFill>
                   <a:srgbClr val="374151"/>
                 </a:solidFill>
@@ -12698,7 +12854,7 @@
               <a:spcAft>
                 <a:spcPts val="800"/>
               </a:spcAft>
-              <a:defRPr sz="1700">
+              <a:defRPr sz="1600">
                 <a:solidFill>
                   <a:srgbClr val="374151"/>
                 </a:solidFill>
@@ -12815,7 +12971,7 @@
                 <a:gridCol w="845820"/>
                 <a:gridCol w="845820"/>
               </a:tblGrid>
-              <a:tr h="374903">
+              <a:tr h="340821">
                 <a:tc>
                   <a:txBody>
                     <a:bodyPr/>
@@ -12913,7 +13069,7 @@
                   </a:tcPr>
                 </a:tc>
               </a:tr>
-              <a:tr h="374903">
+              <a:tr h="340821">
                 <a:tc>
                   <a:txBody>
                     <a:bodyPr/>
@@ -12995,7 +13151,7 @@
                   <a:tcPr/>
                 </a:tc>
               </a:tr>
-              <a:tr h="374903">
+              <a:tr h="340821">
                 <a:tc>
                   <a:txBody>
                     <a:bodyPr/>
@@ -13077,7 +13233,7 @@
                   <a:tcPr/>
                 </a:tc>
               </a:tr>
-              <a:tr h="374903">
+              <a:tr h="340821">
                 <a:tc>
                   <a:txBody>
                     <a:bodyPr/>
@@ -13159,7 +13315,7 @@
                   <a:tcPr/>
                 </a:tc>
               </a:tr>
-              <a:tr h="374903">
+              <a:tr h="340821">
                 <a:tc>
                   <a:txBody>
                     <a:bodyPr/>
@@ -13241,7 +13397,7 @@
                   <a:tcPr/>
                 </a:tc>
               </a:tr>
-              <a:tr h="374903">
+              <a:tr h="340821">
                 <a:tc>
                   <a:txBody>
                     <a:bodyPr/>
@@ -13323,7 +13479,7 @@
                   <a:tcPr/>
                 </a:tc>
               </a:tr>
-              <a:tr h="374903">
+              <a:tr h="340821">
                 <a:tc>
                   <a:txBody>
                     <a:bodyPr/>
@@ -13405,7 +13561,7 @@
                   <a:tcPr/>
                 </a:tc>
               </a:tr>
-              <a:tr h="374903">
+              <a:tr h="340821">
                 <a:tc>
                   <a:txBody>
                     <a:bodyPr/>
@@ -13420,7 +13576,7 @@
                         </a:defRPr>
                       </a:pPr>
                       <a:r>
-                        <a:t>9월</a:t>
+                        <a:t>9월(사)</a:t>
                       </a:r>
                     </a:p>
                   </a:txBody>
@@ -13440,7 +13596,7 @@
                         </a:defRPr>
                       </a:pPr>
                       <a:r>
-                        <a:t>92.4</a:t>
+                        <a:t>92.7</a:t>
                       </a:r>
                     </a:p>
                   </a:txBody>
@@ -13460,7 +13616,7 @@
                         </a:defRPr>
                       </a:pPr>
                       <a:r>
-                        <a:t>79.5</a:t>
+                        <a:t>79.4</a:t>
                       </a:r>
                     </a:p>
                   </a:txBody>
@@ -13487,7 +13643,7 @@
                   <a:tcPr/>
                 </a:tc>
               </a:tr>
-              <a:tr h="374903">
+              <a:tr h="340821">
                 <a:tc>
                   <a:txBody>
                     <a:bodyPr/>
@@ -13502,6 +13658,88 @@
                         </a:defRPr>
                       </a:pPr>
                       <a:r>
+                        <a:t>9월(평)</a:t>
+                      </a:r>
+                    </a:p>
+                  </a:txBody>
+                  <a:tcPr/>
+                </a:tc>
+                <a:tc>
+                  <a:txBody>
+                    <a:bodyPr/>
+                    <a:lstStyle/>
+                    <a:p>
+                      <a:pPr algn="ctr">
+                        <a:defRPr sz="800">
+                          <a:solidFill>
+                            <a:srgbClr val="374151"/>
+                          </a:solidFill>
+                          <a:latin typeface="Malgun Gothic"/>
+                        </a:defRPr>
+                      </a:pPr>
+                      <a:r>
+                        <a:t>92.2</a:t>
+                      </a:r>
+                    </a:p>
+                  </a:txBody>
+                  <a:tcPr/>
+                </a:tc>
+                <a:tc>
+                  <a:txBody>
+                    <a:bodyPr/>
+                    <a:lstStyle/>
+                    <a:p>
+                      <a:pPr algn="ctr">
+                        <a:defRPr sz="800">
+                          <a:solidFill>
+                            <a:srgbClr val="374151"/>
+                          </a:solidFill>
+                          <a:latin typeface="Malgun Gothic"/>
+                        </a:defRPr>
+                      </a:pPr>
+                      <a:r>
+                        <a:t>79.7</a:t>
+                      </a:r>
+                    </a:p>
+                  </a:txBody>
+                  <a:tcPr/>
+                </a:tc>
+                <a:tc>
+                  <a:txBody>
+                    <a:bodyPr/>
+                    <a:lstStyle/>
+                    <a:p>
+                      <a:pPr algn="ctr">
+                        <a:defRPr sz="800">
+                          <a:solidFill>
+                            <a:srgbClr val="374151"/>
+                          </a:solidFill>
+                          <a:latin typeface="Malgun Gothic"/>
+                        </a:defRPr>
+                      </a:pPr>
+                      <a:r>
+                        <a:t>63.5</a:t>
+                      </a:r>
+                    </a:p>
+                  </a:txBody>
+                  <a:tcPr/>
+                </a:tc>
+              </a:tr>
+              <a:tr h="340821">
+                <a:tc>
+                  <a:txBody>
+                    <a:bodyPr/>
+                    <a:lstStyle/>
+                    <a:p>
+                      <a:pPr algn="ctr">
+                        <a:defRPr sz="800">
+                          <a:solidFill>
+                            <a:srgbClr val="374151"/>
+                          </a:solidFill>
+                          <a:latin typeface="Malgun Gothic"/>
+                        </a:defRPr>
+                      </a:pPr>
+                      <a:r>
                         <a:t>10월</a:t>
                       </a:r>
                     </a:p>
@@ -13569,7 +13807,7 @@
                   <a:tcPr/>
                 </a:tc>
               </a:tr>
-              <a:tr h="374912">
+              <a:tr h="340829">
                 <a:tc>
                   <a:txBody>
                     <a:bodyPr/>

</xml_diff>